<commit_message>
Honor Oscar's Final deck: title slide without definition/byline; chronology wording (CJB capable but priced out; 110-gal batch tank)
Co-Authored-By: Claude Fable 5.1 <noreply@anthropic.com>
Claude-Session: https://claude.ai/code/session_01LkE2ZRYs3PLyj8XHTsU3i4
</commit_message>
<xml_diff>
--- a/PVA second supplier initiative/PVA_Second_Supplier_Leadership_Deck_oscar-edit_2026-09-29.pptx
+++ b/PVA second supplier initiative/PVA_Second_Supplier_Leadership_Deck_oscar-edit_2026-09-29.pptx
@@ -9,10 +9,10 @@
   </p:notesMasterIdLst>
   <p:sldIdLst>
     <p:sldId id="256" r:id="rId2"/>
-    <p:sldId id="260" r:id="rId3"/>
-    <p:sldId id="257" r:id="rId4"/>
-    <p:sldId id="258" r:id="rId5"/>
-    <p:sldId id="259" r:id="rId6"/>
+    <p:sldId id="257" r:id="rId3"/>
+    <p:sldId id="258" r:id="rId4"/>
+    <p:sldId id="259" r:id="rId5"/>
+    <p:sldId id="260" r:id="rId6"/>
     <p:sldId id="261" r:id="rId7"/>
     <p:sldId id="262" r:id="rId8"/>
     <p:sldId id="263" r:id="rId9"/>
@@ -160,7 +160,7 @@
     </p:spTree>
     <p:extLst>
       <p:ext uri="{BB962C8B-B14F-4D97-AF65-F5344CB8AC3E}">
-        <p14:creationId xmlns:p14="http://schemas.microsoft.com/office/powerpoint/2010/main" val="3991960916"/>
+        <p14:creationId xmlns:p14="http://schemas.microsoft.com/office/powerpoint/2010/main" val="3350021505"/>
       </p:ext>
     </p:extLst>
   </p:cSld>
@@ -935,7 +935,7 @@
           <a:lstStyle/>
           <a:p>
             <a:r>
-              <a:t>The SNP conversation, in order. One: why we are here - growth, a sole source we depend on, and the intent to run it as a partnership; they should hear investment, not audit. Two: our business, shown - volume history, the forecast of 150 drums this year growing ten percent a year, our delivery record, what the product does for our mission. Three: what we bring - a rolling twelve-month forecast refreshed monthly, a level weekly cadence through a blanket order, and the hydrogel program as a written joint roadmap. Four: growing together - their other hydrogel lines, sodium alginate and guar gum, for our other projects, if R&amp;D has a use. Five: running it as partners - resin supply and a consignment buffer, capacity for year-five volume, cover for the people who run the PVA cook, advance notice of changes, a shelf-life study together; continuity agreed as a shared discipline. Six: a resin-indexed price formula instead of ad hoc increases. Seven: close with a quarterly business review, named contacts and an updated quality agreement. Before we walk in we decide five things: the strategy, which sets the posture - under Option 3 we say a continuity verification lot runs once a year and we do not name the supplier; how much forecast we share and whether a multi-year commitment is on the table; the give - blanket order and payment terms; which projects could use the other hydrogels; and whether we fund the resin buffer and the shelf-life study.</a:t>
+              <a:t>The SNP visit on Tuesday the sixth of October, tentative agenda. One: in the conference room, growth - years of it - and how we could grow the relationship: projects, partnership; and what the synthetics room does, which is where we freeze their PVA into our plates. They should hear investment, not audit. Two: walk them through the synthetics room and show them the synthetic plate we make with their PVA - a supplier rarely sees what its material becomes. Three: back in the conference room, let SNP talk about their other synthetics, and have our R&amp;D talk about projects, what they see in the future, and how we could partner more - possibilities, not commitments. Four: forecasts - what we would share and how that helps their orders and planning; we want agreement on what we share and how often. Still pending: aligning with R&amp;D on what they present, and with Purchasing on what we bring. Before the sixth we fill in five decisions: the strategy, which sets the posture - and under Option 3 whether we mention a continuity verification lot yet; what R&amp;D presents; what Purchasing brings; how much forecast we share; and whether we only listen about their other synthetics or ask for samples and data.</a:t>
             </a:r>
           </a:p>
         </p:txBody>
@@ -4026,7 +4026,7 @@
         <p:spPr>
           <a:xfrm>
             <a:off x="731520" y="1371600"/>
-            <a:ext cx="10698480" cy="707886"/>
+            <a:ext cx="10698480" cy="2651760"/>
           </a:xfrm>
           <a:prstGeom prst="rect">
             <a:avLst/>
@@ -4045,29 +4045,30 @@
               </a:spcAft>
             </a:pPr>
             <a:r>
-              <a:rPr sz="4000" b="1" i="0" dirty="0">
+              <a:rPr sz="4000" b="1" i="0">
                 <a:solidFill>
                   <a:srgbClr val="FFFFFF"/>
                 </a:solidFill>
                 <a:latin typeface="Calibri"/>
               </a:rPr>
-              <a:t>Liquid PVA: </a:t>
-            </a:r>
-            <a:r>
-              <a:rPr lang="en-US" sz="4000" b="1" i="0" dirty="0">
-                <a:solidFill>
-                  <a:srgbClr val="FFFFFF"/>
-                </a:solidFill>
-                <a:latin typeface="Calibri"/>
-              </a:rPr>
-              <a:t>Dual Supplier Discussion</a:t>
-            </a:r>
-            <a:endParaRPr sz="4000" b="1" i="0" dirty="0">
-              <a:solidFill>
-                <a:srgbClr val="FFFFFF"/>
-              </a:solidFill>
-              <a:latin typeface="Calibri"/>
-            </a:endParaRPr>
+              <a:t>Liquid PVA: Dual Supplier Discussion</a:t>
+            </a:r>
+          </a:p>
+          <a:p>
+            <a:pPr algn="l">
+              <a:spcAft>
+                <a:spcPts val="400"/>
+              </a:spcAft>
+            </a:pPr>
+            <a:r>
+              <a:rPr sz="2000" b="0" i="0">
+                <a:solidFill>
+                  <a:srgbClr val="BDD7EE"/>
+                </a:solidFill>
+                <a:latin typeface="Calibri"/>
+              </a:rPr>
+              <a:t>Update: PCI Manufacturing has proven it can make our product — and told us what it costs</a:t>
+            </a:r>
           </a:p>
         </p:txBody>
       </p:sp>
@@ -5778,7 +5779,7 @@
                 </a:solidFill>
                 <a:latin typeface="Calibri"/>
               </a:rPr>
-              <a:t>2 · PCI</a:t>
+              <a:t>1 · HOW WE GOT HERE</a:t>
             </a:r>
           </a:p>
         </p:txBody>
@@ -6588,8 +6589,8 @@
         </p:nvSpPr>
         <p:spPr>
           <a:xfrm>
-            <a:off x="6713727" y="1024128"/>
-            <a:ext cx="1192783" cy="777240"/>
+            <a:off x="6713727" y="1280713"/>
+            <a:ext cx="1192783" cy="520655"/>
           </a:xfrm>
           <a:prstGeom prst="rect">
             <a:avLst/>
@@ -6608,7 +6609,7 @@
               </a:spcAft>
             </a:pPr>
             <a:r>
-              <a:rPr sz="900" b="1" i="0">
+              <a:rPr sz="900" b="1" i="0" dirty="0">
                 <a:solidFill>
                   <a:srgbClr val="B23A2E"/>
                 </a:solidFill>
@@ -6624,13 +6625,31 @@
               </a:spcAft>
             </a:pPr>
             <a:r>
-              <a:rPr sz="900" b="1" i="0">
+              <a:rPr sz="900" b="1" i="0" dirty="0">
                 <a:solidFill>
                   <a:srgbClr val="1F3864"/>
                 </a:solidFill>
                 <a:latin typeface="Calibri"/>
               </a:rPr>
-              <a:t>CJB priced out</a:t>
+              <a:t>CJB </a:t>
+            </a:r>
+            <a:r>
+              <a:rPr lang="en-US" sz="900" b="1" i="0" dirty="0">
+                <a:solidFill>
+                  <a:srgbClr val="1F3864"/>
+                </a:solidFill>
+                <a:latin typeface="Calibri"/>
+              </a:rPr>
+              <a:t>capable but </a:t>
+            </a:r>
+            <a:r>
+              <a:rPr sz="900" b="1" i="0" dirty="0">
+                <a:solidFill>
+                  <a:srgbClr val="1F3864"/>
+                </a:solidFill>
+                <a:latin typeface="Calibri"/>
+              </a:rPr>
+              <a:t>priced out</a:t>
             </a:r>
           </a:p>
         </p:txBody>
@@ -6785,7 +6804,7 @@
         <p:spPr>
           <a:xfrm>
             <a:off x="7943087" y="2011680"/>
-            <a:ext cx="1192783" cy="1005840"/>
+            <a:ext cx="1192783" cy="584775"/>
           </a:xfrm>
           <a:prstGeom prst="rect">
             <a:avLst/>
@@ -6804,13 +6823,31 @@
               </a:spcAft>
             </a:pPr>
             <a:r>
-              <a:rPr sz="800" b="0" i="0">
+              <a:rPr sz="800" b="0" i="0" dirty="0">
                 <a:solidFill>
                   <a:srgbClr val="595959"/>
                 </a:solidFill>
                 <a:latin typeface="Calibri"/>
               </a:rPr>
-              <a:t>Two-plus batches, a dilution study, method work — unpaid</a:t>
+              <a:t>Two-plus batch</a:t>
+            </a:r>
+            <a:r>
+              <a:rPr lang="en-US" sz="800" b="0" i="0" dirty="0">
+                <a:solidFill>
+                  <a:srgbClr val="595959"/>
+                </a:solidFill>
+                <a:latin typeface="Calibri"/>
+              </a:rPr>
+              <a:t> tank (110 gal)</a:t>
+            </a:r>
+            <a:r>
+              <a:rPr sz="800" b="0" i="0" dirty="0">
+                <a:solidFill>
+                  <a:srgbClr val="595959"/>
+                </a:solidFill>
+                <a:latin typeface="Calibri"/>
+              </a:rPr>
+              <a:t>, a dilution study, method work — unpaid</a:t>
             </a:r>
           </a:p>
         </p:txBody>
@@ -7766,7 +7803,7 @@
         <p:spPr>
           <a:xfrm>
             <a:off x="731520" y="4370832"/>
-            <a:ext cx="3246120" cy="838691"/>
+            <a:ext cx="3246120" cy="1362456"/>
           </a:xfrm>
           <a:prstGeom prst="rect">
             <a:avLst/>
@@ -7785,29 +7822,14 @@
               </a:spcAft>
             </a:pPr>
             <a:r>
-              <a:rPr sz="1350" b="1" i="0" dirty="0">
+              <a:rPr sz="1350" b="1" i="0">
                 <a:solidFill>
                   <a:srgbClr val="1F3864"/>
                 </a:solidFill>
                 <a:latin typeface="Calibri"/>
               </a:rPr>
-              <a:t>Capability </a:t>
-            </a:r>
-            <a:r>
-              <a:rPr lang="en-US" sz="1350" b="1" i="0" dirty="0">
-                <a:solidFill>
-                  <a:srgbClr val="1F3864"/>
-                </a:solidFill>
-                <a:latin typeface="Calibri"/>
-              </a:rPr>
-              <a:t>is not common</a:t>
-            </a:r>
-            <a:endParaRPr sz="1350" b="1" i="0" dirty="0">
-              <a:solidFill>
-                <a:srgbClr val="1F3864"/>
-              </a:solidFill>
-              <a:latin typeface="Calibri"/>
-            </a:endParaRPr>
+              <a:t>Capability is not common</a:t>
+            </a:r>
           </a:p>
           <a:p>
             <a:pPr algn="l">
@@ -7816,7 +7838,7 @@
               </a:spcAft>
             </a:pPr>
             <a:r>
-              <a:rPr sz="1000" b="0" i="0" dirty="0">
+              <a:rPr sz="1000" b="0" i="0">
                 <a:solidFill>
                   <a:srgbClr val="595959"/>
                 </a:solidFill>
@@ -8254,7 +8276,7 @@
                 </a:solidFill>
                 <a:latin typeface="Calibri"/>
               </a:rPr>
-              <a:t>1 · COST</a:t>
+              <a:t>2 · COST</a:t>
             </a:r>
           </a:p>
         </p:txBody>
@@ -8765,7 +8787,7 @@
                 </a:solidFill>
                 <a:latin typeface="Calibri"/>
               </a:rPr>
-              <a:t>1 · COST</a:t>
+              <a:t>2 · COST</a:t>
             </a:r>
           </a:p>
         </p:txBody>
@@ -8925,7 +8947,7 @@
                 </a:solidFill>
                 <a:latin typeface="Calibri"/>
               </a:rPr>
-              <a:t>— verified prices of pre-mixed PVA solution by pack size: US composites grade up to 20 gal; ton-scale offshore offers before freight</a:t>
+              <a:t>— verified prices of pre-mixed PVA solution by pack size (US up to 20 gal; offshore ton offers before freight)</a:t>
             </a:r>
           </a:p>
           <a:p>
@@ -8950,7 +8972,7 @@
                 </a:solidFill>
                 <a:latin typeface="Calibri"/>
               </a:rPr>
-              <a:t>— the trend: ~18% lower per doubling of the lot. The band is where 80% of the verified points fall around it; beyond 20 gal its top follows the flattening in vendors' ladders, and its floor is SNP's $0.75 — no US-delivered lot has been seen cheaper (offshore ton offers are before freight and duty). One drum $0.83–3.53; SNP's lot $0.75–3.09; a 5-drum batch $0.75–2.91</a:t>
+              <a:t>— trend ~18% lower per doubling of the lot; the band is where 80% of the points fall. Beyond 20 gal its top follows the flattening in vendors' ladders; its floor is SNP's $0.75 — no US-delivered lot has been seen cheaper. One drum $0.83–3.53; SNP's lot $0.75–3.09; 5-drum batch $0.75–2.91</a:t>
             </a:r>
           </a:p>
           <a:p>
@@ -8975,7 +8997,7 @@
                 </a:solidFill>
                 <a:latin typeface="Calibri"/>
               </a:rPr>
-              <a:t>— $0.75 at ~3 drums a week — the floor of the band, and delivered, to our spec: the cheapest price in the market for a better product</a:t>
+              <a:t>— $0.75 at ~3 drums a week — the floor of the band, delivered and to our spec</a:t>
             </a:r>
           </a:p>
           <a:p>
@@ -9050,7 +9072,7 @@
                 </a:solidFill>
                 <a:latin typeface="Calibri"/>
               </a:rPr>
-              <a:t>— CJB $8.42 at a 40-gal minimum sits far above the band; APV ≥$3 (estimate from our call, never confirmed) sits at the band's top</a:t>
+              <a:t>— CJB $8.42 far above the band; APV ≥$3 (estimate, never confirmed) at its top</a:t>
             </a:r>
           </a:p>
         </p:txBody>
@@ -9282,7 +9304,7 @@
                 </a:solidFill>
                 <a:latin typeface="Calibri"/>
               </a:rPr>
-              <a:t>1 · COST</a:t>
+              <a:t>2 · COST</a:t>
             </a:r>
           </a:p>
         </p:txBody>
@@ -13617,7 +13639,7 @@
         <p:spPr>
           <a:xfrm>
             <a:off x="685800" y="4206240"/>
-            <a:ext cx="3840480" cy="623248"/>
+            <a:ext cx="3840480" cy="731520"/>
           </a:xfrm>
           <a:prstGeom prst="rect">
             <a:avLst/>
@@ -13636,7 +13658,7 @@
               </a:spcAft>
             </a:pPr>
             <a:r>
-              <a:rPr sz="1600" b="1" i="0" dirty="0">
+              <a:rPr sz="1000" b="1" i="0">
                 <a:solidFill>
                   <a:srgbClr val="1F3864"/>
                 </a:solidFill>
@@ -13652,7 +13674,7 @@
               </a:spcAft>
             </a:pPr>
             <a:r>
-              <a:rPr sz="1600" b="0" i="0" dirty="0">
+              <a:rPr sz="1000" b="0" i="0">
                 <a:solidFill>
                   <a:srgbClr val="595959"/>
                 </a:solidFill>
@@ -13917,8 +13939,8 @@
         </p:nvSpPr>
         <p:spPr>
           <a:xfrm>
-            <a:off x="4937760" y="4000105"/>
-            <a:ext cx="3383280" cy="869469"/>
+            <a:off x="4937760" y="4206240"/>
+            <a:ext cx="3383280" cy="731520"/>
           </a:xfrm>
           <a:prstGeom prst="rect">
             <a:avLst/>
@@ -13937,7 +13959,7 @@
               </a:spcAft>
             </a:pPr>
             <a:r>
-              <a:rPr sz="1600" b="1" i="0" dirty="0">
+              <a:rPr sz="1000" b="1" i="0">
                 <a:solidFill>
                   <a:srgbClr val="1F3864"/>
                 </a:solidFill>
@@ -13953,7 +13975,7 @@
               </a:spcAft>
             </a:pPr>
             <a:r>
-              <a:rPr sz="1600" b="0" i="0" dirty="0">
+              <a:rPr sz="1000" b="0" i="0">
                 <a:solidFill>
                   <a:srgbClr val="595959"/>
                 </a:solidFill>
@@ -14199,7 +14221,7 @@
               </a:spcAft>
             </a:pPr>
             <a:r>
-              <a:rPr sz="1050" b="0" i="0" dirty="0">
+              <a:rPr sz="1050" b="0" i="0">
                 <a:solidFill>
                   <a:srgbClr val="595959"/>
                 </a:solidFill>
@@ -14219,7 +14241,7 @@
         <p:spPr>
           <a:xfrm>
             <a:off x="8732520" y="4206240"/>
-            <a:ext cx="2743200" cy="561692"/>
+            <a:ext cx="2743200" cy="731520"/>
           </a:xfrm>
           <a:prstGeom prst="rect">
             <a:avLst/>
@@ -14238,7 +14260,7 @@
               </a:spcAft>
             </a:pPr>
             <a:r>
-              <a:rPr sz="1400" b="1" i="0">
+              <a:rPr sz="1000" b="1" i="0">
                 <a:solidFill>
                   <a:srgbClr val="1F3864"/>
                 </a:solidFill>
@@ -14254,7 +14276,7 @@
               </a:spcAft>
             </a:pPr>
             <a:r>
-              <a:rPr sz="1400" b="0" i="0">
+              <a:rPr sz="1000" b="0" i="0">
                 <a:solidFill>
                   <a:srgbClr val="595959"/>
                 </a:solidFill>
@@ -14553,7 +14575,7 @@
                 </a:solidFill>
                 <a:latin typeface="Calibri"/>
               </a:rPr>
-              <a:t>The SNP Inc. conversation — outline, and what we decide before it</a:t>
+              <a:t>The SNP Inc. visit, Tuesday 6 October — agenda, and what we decide before it</a:t>
             </a:r>
           </a:p>
         </p:txBody>
@@ -14631,7 +14653,7 @@
                 </a:solidFill>
                 <a:latin typeface="Calibri"/>
               </a:rPr>
-              <a:t>The meeting, in order — what we say, and what we want out of each part</a:t>
+              <a:t>Tentative agenda — what we do, and what we want out of each part</a:t>
             </a:r>
           </a:p>
         </p:txBody>
@@ -14644,8 +14666,8 @@
         </p:nvSpPr>
         <p:spPr>
           <a:xfrm>
-            <a:off x="548640" y="1325880"/>
-            <a:ext cx="6949440" cy="3262432"/>
+            <a:off x="548640" y="1371600"/>
+            <a:ext cx="6949440" cy="4480560"/>
           </a:xfrm>
           <a:prstGeom prst="rect">
             <a:avLst/>
@@ -14660,272 +14682,148 @@
           <a:p>
             <a:pPr>
               <a:spcAft>
-                <a:spcPts val="900"/>
-              </a:spcAft>
-            </a:pPr>
-            <a:r>
-              <a:rPr sz="1200" b="1" dirty="0">
+                <a:spcPts val="1200"/>
+              </a:spcAft>
+            </a:pPr>
+            <a:r>
+              <a:rPr sz="1250" b="1">
                 <a:solidFill>
                   <a:srgbClr val="1F3864"/>
                 </a:solidFill>
                 <a:latin typeface="Calibri"/>
               </a:rPr>
-              <a:t>1  Why we are here   </a:t>
-            </a:r>
-            <a:r>
-              <a:rPr sz="1100" dirty="0">
+              <a:t>1  Growth, and the synthetics room   </a:t>
+            </a:r>
+            <a:r>
+              <a:rPr sz="1100">
                 <a:solidFill>
                   <a:srgbClr val="595959"/>
                 </a:solidFill>
                 <a:latin typeface="Calibri"/>
               </a:rPr>
-              <a:t>Years of growth</a:t>
-            </a:r>
-            <a:r>
-              <a:rPr lang="en-US" sz="1100" dirty="0">
+              <a:t>Years of growth. How could we grow the relationship? Projects, partnership. What the synthetics room does — it is where we freeze their PVA into our plates.  </a:t>
+            </a:r>
+            <a:r>
+              <a:rPr sz="1100" b="1">
+                <a:solidFill>
+                  <a:srgbClr val="2E7D46"/>
+                </a:solidFill>
+                <a:latin typeface="Calibri"/>
+              </a:rPr>
+              <a:t>→ They hear investment, not audit</a:t>
+            </a:r>
+          </a:p>
+          <a:p>
+            <a:pPr>
+              <a:spcAft>
+                <a:spcPts val="1200"/>
+              </a:spcAft>
+            </a:pPr>
+            <a:r>
+              <a:rPr sz="1250" b="1">
+                <a:solidFill>
+                  <a:srgbClr val="1F3864"/>
+                </a:solidFill>
+                <a:latin typeface="Calibri"/>
+              </a:rPr>
+              <a:t>2  Walkthrough of the synthetics room   </a:t>
+            </a:r>
+            <a:r>
+              <a:rPr sz="1100">
                 <a:solidFill>
                   <a:srgbClr val="595959"/>
                 </a:solidFill>
                 <a:latin typeface="Calibri"/>
               </a:rPr>
-              <a:t>,  How could we grow the relationship? Projects, </a:t>
-            </a:r>
-            <a:r>
-              <a:rPr sz="1100" dirty="0">
+              <a:t>Show the synthetic plate we make with their PVA, and where it goes from there.  </a:t>
+            </a:r>
+            <a:r>
+              <a:rPr sz="1100" b="1">
+                <a:solidFill>
+                  <a:srgbClr val="2E7D46"/>
+                </a:solidFill>
+                <a:latin typeface="Calibri"/>
+              </a:rPr>
+              <a:t>→ They see the end product their material becomes</a:t>
+            </a:r>
+          </a:p>
+          <a:p>
+            <a:pPr>
+              <a:spcAft>
+                <a:spcPts val="1200"/>
+              </a:spcAft>
+            </a:pPr>
+            <a:r>
+              <a:rPr sz="1250" b="1">
+                <a:solidFill>
+                  <a:srgbClr val="1F3864"/>
+                </a:solidFill>
+                <a:latin typeface="Calibri"/>
+              </a:rPr>
+              <a:t>3  Back in the conference room   </a:t>
+            </a:r>
+            <a:r>
+              <a:rPr sz="1100">
                 <a:solidFill>
                   <a:srgbClr val="595959"/>
                 </a:solidFill>
                 <a:latin typeface="Calibri"/>
               </a:rPr>
-              <a:t>partnership.  </a:t>
-            </a:r>
-            <a:r>
-              <a:rPr sz="1100" b="1" dirty="0">
+              <a:t>SNP talks about their other synthetics. Our R&amp;D talks about projects, what they see in the future, how we could partner more — possibilities, not commitments.  </a:t>
+            </a:r>
+            <a:r>
+              <a:rPr sz="1100" b="1">
                 <a:solidFill>
                   <a:srgbClr val="2E7D46"/>
                 </a:solidFill>
                 <a:latin typeface="Calibri"/>
               </a:rPr>
-              <a:t>→ They hear investment, not audit</a:t>
-            </a:r>
-            <a:r>
-              <a:rPr lang="en-US" sz="1100" b="1" dirty="0">
+              <a:t>→ We learn what else they can make; they hear where we are going</a:t>
+            </a:r>
+          </a:p>
+          <a:p>
+            <a:pPr>
+              <a:spcAft>
+                <a:spcPts val="1200"/>
+              </a:spcAft>
+            </a:pPr>
+            <a:r>
+              <a:rPr sz="1250" b="1">
+                <a:solidFill>
+                  <a:srgbClr val="1F3864"/>
+                </a:solidFill>
+                <a:latin typeface="Calibri"/>
+              </a:rPr>
+              <a:t>4  Forecasts   </a:t>
+            </a:r>
+            <a:r>
+              <a:rPr sz="1100">
+                <a:solidFill>
+                  <a:srgbClr val="595959"/>
+                </a:solidFill>
+                <a:latin typeface="Calibri"/>
+              </a:rPr>
+              <a:t>Sharing our forecast, and how that would help their orders and planning.  </a:t>
+            </a:r>
+            <a:r>
+              <a:rPr sz="1100" b="1">
                 <a:solidFill>
                   <a:srgbClr val="2E7D46"/>
                 </a:solidFill>
                 <a:latin typeface="Calibri"/>
               </a:rPr>
-              <a:t> </a:t>
-            </a:r>
-            <a:endParaRPr sz="1100" b="1" dirty="0">
-              <a:solidFill>
-                <a:srgbClr val="2E7D46"/>
-              </a:solidFill>
-              <a:latin typeface="Calibri"/>
-            </a:endParaRPr>
-          </a:p>
-          <a:p>
-            <a:pPr>
-              <a:spcAft>
-                <a:spcPts val="900"/>
-              </a:spcAft>
-            </a:pPr>
-            <a:r>
-              <a:rPr sz="1200" b="1" dirty="0">
-                <a:solidFill>
-                  <a:srgbClr val="1F3864"/>
-                </a:solidFill>
-                <a:latin typeface="Calibri"/>
-              </a:rPr>
-              <a:t>2  Our business, shown   </a:t>
-            </a:r>
-            <a:r>
-              <a:rPr sz="1100" dirty="0">
-                <a:solidFill>
-                  <a:srgbClr val="595959"/>
-                </a:solidFill>
-                <a:latin typeface="Calibri"/>
-              </a:rPr>
-              <a:t>Volume history, the forecast (150 drums this year, +10%/yr), our delivery record, what the product does for our mission.  </a:t>
-            </a:r>
-            <a:r>
-              <a:rPr sz="1100" b="1" dirty="0">
-                <a:solidFill>
-                  <a:srgbClr val="2E7D46"/>
-                </a:solidFill>
-                <a:latin typeface="Calibri"/>
-              </a:rPr>
-              <a:t>→ A growing account worth planning for</a:t>
-            </a:r>
-          </a:p>
-          <a:p>
-            <a:pPr>
-              <a:spcAft>
-                <a:spcPts val="900"/>
-              </a:spcAft>
-            </a:pPr>
-            <a:r>
-              <a:rPr sz="1200" b="1" dirty="0">
-                <a:solidFill>
-                  <a:srgbClr val="1F3864"/>
-                </a:solidFill>
-                <a:latin typeface="Calibri"/>
-              </a:rPr>
-              <a:t>3  What we bring   </a:t>
-            </a:r>
-            <a:r>
-              <a:rPr sz="1100" dirty="0">
-                <a:solidFill>
-                  <a:srgbClr val="595959"/>
-                </a:solidFill>
-                <a:latin typeface="Calibri"/>
-              </a:rPr>
-              <a:t>Rolling 12-month forecast refreshed monthly; a level weekly cadence through a blanket order; the hydrogel program as a written joint roadmap.  </a:t>
-            </a:r>
-            <a:r>
-              <a:rPr sz="1100" b="1" dirty="0">
-                <a:solidFill>
-                  <a:srgbClr val="2E7D46"/>
-                </a:solidFill>
-                <a:latin typeface="Calibri"/>
-              </a:rPr>
-              <a:t>→ Predictability for their kettle and resin buys</a:t>
-            </a:r>
-          </a:p>
-          <a:p>
-            <a:pPr>
-              <a:spcAft>
-                <a:spcPts val="900"/>
-              </a:spcAft>
-            </a:pPr>
-            <a:r>
-              <a:rPr sz="1200" b="1" dirty="0">
-                <a:solidFill>
-                  <a:srgbClr val="1F3864"/>
-                </a:solidFill>
-                <a:latin typeface="Calibri"/>
-              </a:rPr>
-              <a:t>4  Growing together   </a:t>
-            </a:r>
-            <a:r>
-              <a:rPr sz="1100" dirty="0">
-                <a:solidFill>
-                  <a:srgbClr val="595959"/>
-                </a:solidFill>
-                <a:latin typeface="Calibri"/>
-              </a:rPr>
-              <a:t>Their other hydrogel lines — sodium alginate, guar gum — for our other projects.  </a:t>
-            </a:r>
-            <a:r>
-              <a:rPr sz="1100" b="1" dirty="0">
-                <a:solidFill>
-                  <a:srgbClr val="2E7D46"/>
-                </a:solidFill>
-                <a:latin typeface="Calibri"/>
-              </a:rPr>
-              <a:t>→ A second and third line, if R&amp;D has a use</a:t>
-            </a:r>
-          </a:p>
-          <a:p>
-            <a:pPr>
-              <a:spcAft>
-                <a:spcPts val="900"/>
-              </a:spcAft>
-            </a:pPr>
-            <a:r>
-              <a:rPr sz="1200" b="1" dirty="0">
-                <a:solidFill>
-                  <a:srgbClr val="1F3864"/>
-                </a:solidFill>
-                <a:latin typeface="Calibri"/>
-              </a:rPr>
-              <a:t>5  Running it as partners   </a:t>
-            </a:r>
-            <a:r>
-              <a:rPr sz="1100" dirty="0">
-                <a:solidFill>
-                  <a:srgbClr val="595959"/>
-                </a:solidFill>
-                <a:latin typeface="Calibri"/>
-              </a:rPr>
-              <a:t>Resin supply and a consignment buffer; capacity for Year-5 volume; cover for the people who run the PVA cook; advance notice of changes; a shelf-life study together.  </a:t>
-            </a:r>
-            <a:r>
-              <a:rPr sz="1100" b="1" dirty="0">
-                <a:solidFill>
-                  <a:srgbClr val="2E7D46"/>
-                </a:solidFill>
-                <a:latin typeface="Calibri"/>
-              </a:rPr>
-              <a:t>→ Continuity agreed as a shared discipline, not a demand</a:t>
-            </a:r>
-          </a:p>
-          <a:p>
-            <a:pPr>
-              <a:spcAft>
-                <a:spcPts val="900"/>
-              </a:spcAft>
-            </a:pPr>
-            <a:r>
-              <a:rPr sz="1200" b="1" dirty="0">
-                <a:solidFill>
-                  <a:srgbClr val="1F3864"/>
-                </a:solidFill>
-                <a:latin typeface="Calibri"/>
-              </a:rPr>
-              <a:t>6  Price   </a:t>
-            </a:r>
-            <a:r>
-              <a:rPr sz="1100" dirty="0">
-                <a:solidFill>
-                  <a:srgbClr val="595959"/>
-                </a:solidFill>
-                <a:latin typeface="Calibri"/>
-              </a:rPr>
-              <a:t>A resin-indexed formula in place of ad hoc increases.  </a:t>
-            </a:r>
-            <a:r>
-              <a:rPr sz="1100" b="1" dirty="0">
-                <a:solidFill>
-                  <a:srgbClr val="2E7D46"/>
-                </a:solidFill>
-                <a:latin typeface="Calibri"/>
-              </a:rPr>
-              <a:t>→ Predictability for both sides</a:t>
-            </a:r>
-          </a:p>
-          <a:p>
-            <a:pPr>
-              <a:spcAft>
-                <a:spcPts val="900"/>
-              </a:spcAft>
-            </a:pPr>
-            <a:r>
-              <a:rPr sz="1200" b="1" dirty="0">
-                <a:solidFill>
-                  <a:srgbClr val="1F3864"/>
-                </a:solidFill>
-                <a:latin typeface="Calibri"/>
-              </a:rPr>
-              <a:t>7  Close   </a:t>
-            </a:r>
-            <a:r>
-              <a:rPr sz="1100" dirty="0">
-                <a:solidFill>
-                  <a:srgbClr val="595959"/>
-                </a:solidFill>
-                <a:latin typeface="Calibri"/>
-              </a:rPr>
-              <a:t>Quarterly business review, named contacts, an updated Supplier Quality Agreement (SQA).  </a:t>
-            </a:r>
-            <a:r>
-              <a:rPr sz="1100" b="1" dirty="0">
-                <a:solidFill>
-                  <a:srgbClr val="2E7D46"/>
-                </a:solidFill>
-                <a:latin typeface="Calibri"/>
-              </a:rPr>
-              <a:t>→ A cadence that keeps it alive</a:t>
+              <a:t>→ Agreement on what we share, and how often</a:t>
+            </a:r>
+          </a:p>
+          <a:p>
+            <a:r>
+              <a:rPr sz="1050" i="1">
+                <a:solidFill>
+                  <a:srgbClr val="9C5A0C"/>
+                </a:solidFill>
+                <a:latin typeface="Calibri"/>
+              </a:rPr>
+              <a:t>Pending: align with R&amp;D on what they present · align with Purchasing on what we bring and say</a:t>
             </a:r>
           </a:p>
         </p:txBody>
@@ -15011,7 +14909,7 @@
                 </a:solidFill>
                 <a:latin typeface="Calibri"/>
               </a:rPr>
-              <a:t>Decide before we walk in</a:t>
+              <a:t>Decisions to fill in before 6 October</a:t>
             </a:r>
           </a:p>
           <a:p>
@@ -15036,7 +14934,7 @@
                 </a:solidFill>
                 <a:latin typeface="Calibri"/>
               </a:rPr>
-              <a:t>— sets the whole posture. Under Option 3 we say a continuity verification lot runs once a year; the supplier is not named. (Leadership)</a:t>
+              <a:t>— sets the posture for the whole visit. Under Option 3: do we mention a continuity verification lot, or not yet? — ________ (Leadership)</a:t>
             </a:r>
           </a:p>
           <a:p>
@@ -15052,7 +14950,7 @@
                 </a:solidFill>
                 <a:latin typeface="Calibri"/>
               </a:rPr>
-              <a:t>How much forecast, what commitment  </a:t>
+              <a:t>What R&amp;D presents  </a:t>
             </a:r>
             <a:r>
               <a:rPr sz="1000">
@@ -15061,7 +14959,7 @@
                 </a:solidFill>
                 <a:latin typeface="Calibri"/>
               </a:rPr>
-              <a:t>— 12-month rolling and a 3-year outlook; whether a multi-year commitment or letter of intent is on the table. (Leadership, Legal)</a:t>
+              <a:t>— which projects, how far into the future, what we are willing to show — ________ (R&amp;D)</a:t>
             </a:r>
           </a:p>
           <a:p>
@@ -15077,7 +14975,7 @@
                 </a:solidFill>
                 <a:latin typeface="Calibri"/>
               </a:rPr>
-              <a:t>The give  </a:t>
+              <a:t>What Purchasing brings  </a:t>
             </a:r>
             <a:r>
               <a:rPr sz="1000">
@@ -15086,7 +14984,7 @@
                 </a:solidFill>
                 <a:latin typeface="Calibri"/>
               </a:rPr>
-              <a:t>— blanket order — yes or no; payment terms as a lever — yes or no. (Finance, Supply Chain)</a:t>
+              <a:t>— forecast format and refresh cadence; blanket order or not; anything on terms — ________ (Purchasing)</a:t>
             </a:r>
           </a:p>
           <a:p>
@@ -15102,7 +15000,7 @@
                 </a:solidFill>
                 <a:latin typeface="Calibri"/>
               </a:rPr>
-              <a:t>The other hydrogels  </a:t>
+              <a:t>How much forecast we share  </a:t>
             </a:r>
             <a:r>
               <a:rPr sz="1000">
@@ -15111,7 +15009,7 @@
                 </a:solidFill>
                 <a:latin typeface="Calibri"/>
               </a:rPr>
-              <a:t>— which projects could use alginate or guar, at what solids. (R&amp;D, before the meeting)</a:t>
+              <a:t>— 12-month rolling; a 3-year outlook or not — ________ (Leadership)</a:t>
             </a:r>
           </a:p>
           <a:p>
@@ -15127,7 +15025,7 @@
                 </a:solidFill>
                 <a:latin typeface="Calibri"/>
               </a:rPr>
-              <a:t>Continuity money  </a:t>
+              <a:t>Their other synthetics  </a:t>
             </a:r>
             <a:r>
               <a:rPr sz="1000">
@@ -15136,7 +15034,7 @@
                 </a:solidFill>
                 <a:latin typeface="Calibri"/>
               </a:rPr>
-              <a:t>— fund the resin buffer (~$2–6k tied up) and the shelf-life study — or not. (Supply Chain)</a:t>
+              <a:t>— listen only, or ask for samples and data — ________ (R&amp;D, Supply Chain)</a:t>
             </a:r>
           </a:p>
         </p:txBody>
@@ -15220,7 +15118,7 @@
                 </a:solidFill>
                 <a:latin typeface="Calibri"/>
               </a:rPr>
-              <a:t>Decide the strategy and the give before the meeting; the meeting is where we execute the partnership, not where we discover it.</a:t>
+              <a:t>Decide the strategy and what R&amp;D and Purchasing bring before 6 October; the visit is where we grow the relationship, not where we discover our own position.</a:t>
             </a:r>
           </a:p>
         </p:txBody>

</xml_diff>